<commit_message>
Sumar GitHub como desafío opcional y publicar en Posit Connect Cloud
- Clase 1 explica cómo trabajar en un proyecto de RStudio y suma dos láminas
  y una sección de primeros_pasos.R con GitHub como desafío opcional.
- Clase 7 publica en Posit Connect Cloud con rsconnect en lugar de
  shinyapps.io (deploy.R y láminas).
- Clase Extra y README actualizados a Posit Connect Cloud.
</commit_message>
<xml_diff>
--- a/revisor_corpus/clase_extra.pptx
+++ b/revisor_corpus/clase_extra.pptx
@@ -3221,7 +3221,7 @@
                 <a:ea typeface="Calibri" pitchFamily="34" charset="-122"/>
                 <a:cs typeface="Calibri" pitchFamily="34" charset="-120"/>
               </a:rPr>
-              <a:t>Revisá tu corpus con esta app, adaptá la app de la Clase 7 a tus columnas y publicala en shinyapps.io.</a:t>
+              <a:t>Revisá tu corpus con esta app, adaptá la app de la Clase 7 a tus columnas y publicala en Posit Connect Cloud.</a:t>
             </a:r>
             <a:endParaRPr lang="en-US" sz="1700" dirty="0"/>
           </a:p>
@@ -7381,7 +7381,7 @@
                 <a:ea typeface="Calibri" pitchFamily="34" charset="-122"/>
                 <a:cs typeface="Calibri" pitchFamily="34" charset="-120"/>
               </a:rPr>
-              <a:t>Horas de uso por mes y memoria limitadas en shinyapps.io.</a:t>
+              <a:t>Horas de uso y memoria limitadas en Posit Connect Cloud.</a:t>
             </a:r>
             <a:endParaRPr lang="en-US" sz="1050" dirty="0"/>
           </a:p>

</xml_diff>